<commit_message>
fix(materials): validate and correct final A components
</commit_message>
<xml_diff>
--- a/docs/submission/claude-final-materials/A-FINAL-COMPONENT.pptx
+++ b/docs/submission/claude-final-materials/A-FINAL-COMPONENT.pptx
@@ -2,18 +2,18 @@
 <file path=ppt/presentation.xml><?xml version="1.0" encoding="utf-8"?>
 <p:presentation xmlns:p="http://schemas.openxmlformats.org/presentationml/2006/main">
   <p:sldMasterIdLst>
-    <p:sldMasterId xmlns:r="http://schemas.openxmlformats.org/officeDocument/2006/relationships" id="2147483648" r:id="R2ca74e15e26449bb"/>
+    <p:sldMasterId xmlns:r="http://schemas.openxmlformats.org/officeDocument/2006/relationships" id="2147483648" r:id="R198e39c33fab48fc"/>
   </p:sldMasterIdLst>
   <p:notesMasterIdLst>
-    <p:notesMasterId xmlns:r="http://schemas.openxmlformats.org/officeDocument/2006/relationships" r:id="R41eb9d37e95c457c"/>
+    <p:notesMasterId xmlns:r="http://schemas.openxmlformats.org/officeDocument/2006/relationships" r:id="Rd5f47419fb10407a"/>
   </p:notesMasterIdLst>
   <p:sldIdLst>
-    <p:sldId xmlns:r="http://schemas.openxmlformats.org/officeDocument/2006/relationships" id="256" r:id="Rb015efa6ee374572"/>
-    <p:sldId xmlns:r="http://schemas.openxmlformats.org/officeDocument/2006/relationships" id="257" r:id="R237fd2d1afae482c"/>
-    <p:sldId xmlns:r="http://schemas.openxmlformats.org/officeDocument/2006/relationships" id="258" r:id="Rcc9e975b67064524"/>
-    <p:sldId xmlns:r="http://schemas.openxmlformats.org/officeDocument/2006/relationships" id="259" r:id="Rd258b2df74574738"/>
-    <p:sldId xmlns:r="http://schemas.openxmlformats.org/officeDocument/2006/relationships" id="260" r:id="Rf8236740216f4c23"/>
-    <p:sldId xmlns:r="http://schemas.openxmlformats.org/officeDocument/2006/relationships" id="261" r:id="Red04f2485a434c40"/>
+    <p:sldId xmlns:r="http://schemas.openxmlformats.org/officeDocument/2006/relationships" id="256" r:id="R1bf3077e15344753"/>
+    <p:sldId xmlns:r="http://schemas.openxmlformats.org/officeDocument/2006/relationships" id="257" r:id="R4e303f1a328a4fb1"/>
+    <p:sldId xmlns:r="http://schemas.openxmlformats.org/officeDocument/2006/relationships" id="258" r:id="R1fc8003a709d4d43"/>
+    <p:sldId xmlns:r="http://schemas.openxmlformats.org/officeDocument/2006/relationships" id="259" r:id="R77595a8256b24026"/>
+    <p:sldId xmlns:r="http://schemas.openxmlformats.org/officeDocument/2006/relationships" id="260" r:id="R3ced44106e294946"/>
+    <p:sldId xmlns:r="http://schemas.openxmlformats.org/officeDocument/2006/relationships" id="261" r:id="R85c9d36c15624ec6"/>
   </p:sldIdLst>
   <p:sldSz cx="12192000" cy="6858000"/>
   <p:notesSz cx="6858000" cy="9144000"/>
@@ -934,7 +934,7 @@
           <p:cNvPr id="3" name="Title">
             <a:extLst xmlns:a="http://schemas.openxmlformats.org/drawingml/2006/main">
               <a:ext uri="{FF2B5EF4-FFF2-40B4-BE49-F238E27FC236}">
-                <a16:creationId xmlns:a16="http://schemas.microsoft.com/office/drawing/2014/main" id="{CCC6904B-3D9A-46C5-BED9-7453337D9FEB}"/>
+                <a16:creationId xmlns:a16="http://schemas.microsoft.com/office/drawing/2014/main" id="{53D15A25-2607-4DFC-8D42-932A485DF6EE}"/>
               </a:ext>
             </a:extLst>
           </p:cNvPr>
@@ -1163,7 +1163,7 @@
           <p:cNvPr id="2" name="Subtitle">
             <a:extLst xmlns:a="http://schemas.openxmlformats.org/drawingml/2006/main">
               <a:ext uri="{FF2B5EF4-FFF2-40B4-BE49-F238E27FC236}">
-                <a16:creationId xmlns:a16="http://schemas.microsoft.com/office/drawing/2014/main" id="{7CCA3D8E-9008-4976-A1F3-24AAB2CAA5E3}"/>
+                <a16:creationId xmlns:a16="http://schemas.microsoft.com/office/drawing/2014/main" id="{DAC47256-17C4-4203-94BF-FBBE56F35A6B}"/>
               </a:ext>
             </a:extLst>
           </p:cNvPr>
@@ -1409,7 +1409,7 @@
           <p:cNvPr id="2" name="Section title">
             <a:extLst xmlns:a="http://schemas.openxmlformats.org/drawingml/2006/main">
               <a:ext uri="{FF2B5EF4-FFF2-40B4-BE49-F238E27FC236}">
-                <a16:creationId xmlns:a16="http://schemas.microsoft.com/office/drawing/2014/main" id="{0F78A2C2-8F3B-4F56-AB6A-FFA5F206DBCB}"/>
+                <a16:creationId xmlns:a16="http://schemas.microsoft.com/office/drawing/2014/main" id="{8E67836D-9549-49C6-856A-2DBB6898857B}"/>
               </a:ext>
             </a:extLst>
           </p:cNvPr>
@@ -1655,7 +1655,7 @@
           <p:cNvPr id="3" name="Title">
             <a:extLst xmlns:a="http://schemas.openxmlformats.org/drawingml/2006/main">
               <a:ext uri="{FF2B5EF4-FFF2-40B4-BE49-F238E27FC236}">
-                <a16:creationId xmlns:a16="http://schemas.microsoft.com/office/drawing/2014/main" id="{1FE463F4-8A34-4640-B48B-5BFB0D3C479B}"/>
+                <a16:creationId xmlns:a16="http://schemas.microsoft.com/office/drawing/2014/main" id="{8DDC8D8A-7835-4D29-B1BF-29956DEF120E}"/>
               </a:ext>
             </a:extLst>
           </p:cNvPr>
@@ -1884,7 +1884,7 @@
           <p:cNvPr id="2" name="Body">
             <a:extLst xmlns:a="http://schemas.openxmlformats.org/drawingml/2006/main">
               <a:ext uri="{FF2B5EF4-FFF2-40B4-BE49-F238E27FC236}">
-                <a16:creationId xmlns:a16="http://schemas.microsoft.com/office/drawing/2014/main" id="{B1803D42-3384-4B65-B6A2-BE6DDA1C91B7}"/>
+                <a16:creationId xmlns:a16="http://schemas.microsoft.com/office/drawing/2014/main" id="{8E1A032F-4848-4113-A4D0-D1D8216E47FF}"/>
               </a:ext>
             </a:extLst>
           </p:cNvPr>
@@ -2130,7 +2130,7 @@
           <p:cNvPr id="4" name="Title">
             <a:extLst xmlns:a="http://schemas.openxmlformats.org/drawingml/2006/main">
               <a:ext uri="{FF2B5EF4-FFF2-40B4-BE49-F238E27FC236}">
-                <a16:creationId xmlns:a16="http://schemas.microsoft.com/office/drawing/2014/main" id="{6CA7A047-31CB-467A-BCA0-CE449A3A1759}"/>
+                <a16:creationId xmlns:a16="http://schemas.microsoft.com/office/drawing/2014/main" id="{D2515D6D-4BCE-4CC9-8D2E-51908BABEB6A}"/>
               </a:ext>
             </a:extLst>
           </p:cNvPr>
@@ -2359,7 +2359,7 @@
           <p:cNvPr id="2" name="Left column">
             <a:extLst xmlns:a="http://schemas.openxmlformats.org/drawingml/2006/main">
               <a:ext uri="{FF2B5EF4-FFF2-40B4-BE49-F238E27FC236}">
-                <a16:creationId xmlns:a16="http://schemas.microsoft.com/office/drawing/2014/main" id="{DA840671-1114-48B1-86EE-B30FFE0A62CC}"/>
+                <a16:creationId xmlns:a16="http://schemas.microsoft.com/office/drawing/2014/main" id="{A2295370-8447-4F08-A46B-6C9EE8676AE2}"/>
               </a:ext>
             </a:extLst>
           </p:cNvPr>
@@ -2588,7 +2588,7 @@
           <p:cNvPr id="3" name="Right column">
             <a:extLst xmlns:a="http://schemas.openxmlformats.org/drawingml/2006/main">
               <a:ext uri="{FF2B5EF4-FFF2-40B4-BE49-F238E27FC236}">
-                <a16:creationId xmlns:a16="http://schemas.microsoft.com/office/drawing/2014/main" id="{78CD844A-8B89-4D26-9726-9F90F95EBF28}"/>
+                <a16:creationId xmlns:a16="http://schemas.microsoft.com/office/drawing/2014/main" id="{010FF4E3-E042-426F-A69D-E5C55D99DDFA}"/>
               </a:ext>
             </a:extLst>
           </p:cNvPr>
@@ -2834,7 +2834,7 @@
           <p:cNvPr id="3" name="Title">
             <a:extLst xmlns:a="http://schemas.openxmlformats.org/drawingml/2006/main">
               <a:ext uri="{FF2B5EF4-FFF2-40B4-BE49-F238E27FC236}">
-                <a16:creationId xmlns:a16="http://schemas.microsoft.com/office/drawing/2014/main" id="{C59A4625-5CE0-44E5-BE7A-FE226CC01BD0}"/>
+                <a16:creationId xmlns:a16="http://schemas.microsoft.com/office/drawing/2014/main" id="{243E2DF9-06E5-49DA-8243-CEEB35FF8337}"/>
               </a:ext>
             </a:extLst>
           </p:cNvPr>
@@ -3063,7 +3063,7 @@
           <p:cNvPr id="2" name="Left column">
             <a:extLst xmlns:a="http://schemas.openxmlformats.org/drawingml/2006/main">
               <a:ext uri="{FF2B5EF4-FFF2-40B4-BE49-F238E27FC236}">
-                <a16:creationId xmlns:a16="http://schemas.microsoft.com/office/drawing/2014/main" id="{C673600E-1A67-4FC8-8DA4-F68F50EF7969}"/>
+                <a16:creationId xmlns:a16="http://schemas.microsoft.com/office/drawing/2014/main" id="{FEBD7877-EE2A-4BD9-877D-F25B7870A20B}"/>
               </a:ext>
             </a:extLst>
           </p:cNvPr>
@@ -3330,12 +3330,12 @@
   </p:cSld>
   <p:clrMap bg1="lt1" tx1="dk1" bg2="lt2" tx2="dk2" accent1="accent1" accent2="accent2" accent3="accent3" accent4="accent4" accent5="accent5" accent6="accent6" hlink="hlink" folHlink="folHlink"/>
   <p:sldLayoutIdLst>
-    <p:sldLayoutId xmlns:r="http://schemas.openxmlformats.org/officeDocument/2006/relationships" id="2147483649" r:id="Rcf1d212db2844ce8"/>
-    <p:sldLayoutId xmlns:r="http://schemas.openxmlformats.org/officeDocument/2006/relationships" id="2147483650" r:id="Rd141d459a545488e"/>
-    <p:sldLayoutId xmlns:r="http://schemas.openxmlformats.org/officeDocument/2006/relationships" id="2147483651" r:id="R4b964e0c7bfb4fc9"/>
-    <p:sldLayoutId xmlns:r="http://schemas.openxmlformats.org/officeDocument/2006/relationships" id="2147483652" r:id="R2b91e9a9c81a4982"/>
-    <p:sldLayoutId xmlns:r="http://schemas.openxmlformats.org/officeDocument/2006/relationships" id="2147483653" r:id="R7d884451770d49b8"/>
-    <p:sldLayoutId xmlns:r="http://schemas.openxmlformats.org/officeDocument/2006/relationships" id="2147483654" r:id="R5115deb1f89b4820"/>
+    <p:sldLayoutId xmlns:r="http://schemas.openxmlformats.org/officeDocument/2006/relationships" id="2147483649" r:id="R0c23e21051e34b81"/>
+    <p:sldLayoutId xmlns:r="http://schemas.openxmlformats.org/officeDocument/2006/relationships" id="2147483650" r:id="Re849ae78b0c841c4"/>
+    <p:sldLayoutId xmlns:r="http://schemas.openxmlformats.org/officeDocument/2006/relationships" id="2147483651" r:id="R763616f79b064515"/>
+    <p:sldLayoutId xmlns:r="http://schemas.openxmlformats.org/officeDocument/2006/relationships" id="2147483652" r:id="R88c233adb49f4eea"/>
+    <p:sldLayoutId xmlns:r="http://schemas.openxmlformats.org/officeDocument/2006/relationships" id="2147483653" r:id="R45777a8a5ccb45ba"/>
+    <p:sldLayoutId xmlns:r="http://schemas.openxmlformats.org/officeDocument/2006/relationships" id="2147483654" r:id="Rfb409fc3efb44ac5"/>
   </p:sldLayoutIdLst>
   <p:txStyles>
     <p:titleStyle>
@@ -3886,7 +3886,7 @@
           <p:cNvPr id="9" name="">
             <a:extLst xmlns:a="http://schemas.openxmlformats.org/drawingml/2006/main">
               <a:ext uri="{FF2B5EF4-FFF2-40B4-BE49-F238E27FC236}">
-                <a16:creationId xmlns:a16="http://schemas.microsoft.com/office/drawing/2014/main" id="{BBCFA2C6-9046-4E46-A284-C82991EFC596}"/>
+                <a16:creationId xmlns:a16="http://schemas.microsoft.com/office/drawing/2014/main" id="{BB7B2244-E120-4D26-AD67-BC3405C8B0CB}"/>
               </a:ext>
             </a:extLst>
           </p:cNvPr>
@@ -4043,7 +4043,7 @@
           <p:cNvPr id="2" name="">
             <a:extLst xmlns:a="http://schemas.openxmlformats.org/drawingml/2006/main">
               <a:ext uri="{FF2B5EF4-FFF2-40B4-BE49-F238E27FC236}">
-                <a16:creationId xmlns:a16="http://schemas.microsoft.com/office/drawing/2014/main" id="{C039EB82-89CA-4C67-96E6-C66D4BB95D75}"/>
+                <a16:creationId xmlns:a16="http://schemas.microsoft.com/office/drawing/2014/main" id="{A917E62E-CA4B-4B0E-A70C-F69498E63CEA}"/>
               </a:ext>
             </a:extLst>
           </p:cNvPr>
@@ -4200,7 +4200,7 @@
           <p:cNvPr id="3" name="">
             <a:extLst xmlns:a="http://schemas.openxmlformats.org/drawingml/2006/main">
               <a:ext uri="{FF2B5EF4-FFF2-40B4-BE49-F238E27FC236}">
-                <a16:creationId xmlns:a16="http://schemas.microsoft.com/office/drawing/2014/main" id="{D620D025-43CC-49C8-97CE-DA0289203B98}"/>
+                <a16:creationId xmlns:a16="http://schemas.microsoft.com/office/drawing/2014/main" id="{E7E73A34-2B96-4221-B431-280183078F79}"/>
               </a:ext>
             </a:extLst>
           </p:cNvPr>
@@ -4415,7 +4415,7 @@
           <p:cNvPr id="4" name="">
             <a:extLst xmlns:a="http://schemas.openxmlformats.org/drawingml/2006/main">
               <a:ext uri="{FF2B5EF4-FFF2-40B4-BE49-F238E27FC236}">
-                <a16:creationId xmlns:a16="http://schemas.microsoft.com/office/drawing/2014/main" id="{3C7EEE32-E797-4C0D-A7CD-77F6579C6A8D}"/>
+                <a16:creationId xmlns:a16="http://schemas.microsoft.com/office/drawing/2014/main" id="{0A0C47C8-4CB0-46EA-A94A-5D2E84137CA6}"/>
               </a:ext>
             </a:extLst>
           </p:cNvPr>
@@ -4572,7 +4572,7 @@
           <p:cNvPr id="5" name="">
             <a:extLst xmlns:a="http://schemas.openxmlformats.org/drawingml/2006/main">
               <a:ext uri="{FF2B5EF4-FFF2-40B4-BE49-F238E27FC236}">
-                <a16:creationId xmlns:a16="http://schemas.microsoft.com/office/drawing/2014/main" id="{A5D0E733-D5CF-4521-8F29-A13FE30B687B}"/>
+                <a16:creationId xmlns:a16="http://schemas.microsoft.com/office/drawing/2014/main" id="{E8A27B06-4005-4085-A11B-D04A2E64D878}"/>
               </a:ext>
             </a:extLst>
           </p:cNvPr>
@@ -4854,7 +4854,7 @@
           <p:cNvPr id="6" name="">
             <a:extLst xmlns:a="http://schemas.openxmlformats.org/drawingml/2006/main">
               <a:ext uri="{FF2B5EF4-FFF2-40B4-BE49-F238E27FC236}">
-                <a16:creationId xmlns:a16="http://schemas.microsoft.com/office/drawing/2014/main" id="{AC648018-92C5-4EEE-86EF-153076FB69E7}"/>
+                <a16:creationId xmlns:a16="http://schemas.microsoft.com/office/drawing/2014/main" id="{A3A6AB8E-C896-400E-9658-366C3CC2BB73}"/>
               </a:ext>
             </a:extLst>
           </p:cNvPr>
@@ -5011,7 +5011,7 @@
           <p:cNvPr id="7" name="">
             <a:extLst xmlns:a="http://schemas.openxmlformats.org/drawingml/2006/main">
               <a:ext uri="{FF2B5EF4-FFF2-40B4-BE49-F238E27FC236}">
-                <a16:creationId xmlns:a16="http://schemas.microsoft.com/office/drawing/2014/main" id="{83B3333D-8E9B-461B-8F50-E5E19B930CF3}"/>
+                <a16:creationId xmlns:a16="http://schemas.microsoft.com/office/drawing/2014/main" id="{9FD53D23-F793-4554-985A-B6E27867DDF6}"/>
               </a:ext>
             </a:extLst>
           </p:cNvPr>
@@ -5256,7 +5256,7 @@
           <p:cNvPr id="8" name="">
             <a:extLst xmlns:a="http://schemas.openxmlformats.org/drawingml/2006/main">
               <a:ext uri="{FF2B5EF4-FFF2-40B4-BE49-F238E27FC236}">
-                <a16:creationId xmlns:a16="http://schemas.microsoft.com/office/drawing/2014/main" id="{BDF1149F-983C-45D4-A598-0D38444C4FCC}"/>
+                <a16:creationId xmlns:a16="http://schemas.microsoft.com/office/drawing/2014/main" id="{31ABB175-A075-41C5-9810-95F65EB69A4A}"/>
               </a:ext>
             </a:extLst>
           </p:cNvPr>
@@ -5411,7 +5411,7 @@
     </p:spTree>
     <p:extLst>
       <p:ext uri="{BB962C8B-B14F-4D97-AF65-F5344CB8AC3E}">
-        <p14:creationId xmlns:p14="http://schemas.microsoft.com/office/powerpoint/2010/main" val="70420104"/>
+        <p14:creationId xmlns:p14="http://schemas.microsoft.com/office/powerpoint/2010/main" val="232249580"/>
       </p:ext>
     </p:extLst>
   </p:cSld>
@@ -5442,7 +5442,7 @@
           <p:cNvPr id="6" name="">
             <a:extLst xmlns:a="http://schemas.openxmlformats.org/drawingml/2006/main">
               <a:ext uri="{FF2B5EF4-FFF2-40B4-BE49-F238E27FC236}">
-                <a16:creationId xmlns:a16="http://schemas.microsoft.com/office/drawing/2014/main" id="{E20B7A7C-5603-4312-A61F-02889319E037}"/>
+                <a16:creationId xmlns:a16="http://schemas.microsoft.com/office/drawing/2014/main" id="{00CC459B-7A57-4129-904D-66BDD84688A6}"/>
               </a:ext>
             </a:extLst>
           </p:cNvPr>
@@ -5599,7 +5599,7 @@
           <p:cNvPr id="2" name="">
             <a:extLst xmlns:a="http://schemas.openxmlformats.org/drawingml/2006/main">
               <a:ext uri="{FF2B5EF4-FFF2-40B4-BE49-F238E27FC236}">
-                <a16:creationId xmlns:a16="http://schemas.microsoft.com/office/drawing/2014/main" id="{B02501CA-EFF8-415C-A1D6-2998CC5C0A16}"/>
+                <a16:creationId xmlns:a16="http://schemas.microsoft.com/office/drawing/2014/main" id="{F48A8EA0-A2D9-4FE9-BC71-E4F09D82D75F}"/>
               </a:ext>
             </a:extLst>
           </p:cNvPr>
@@ -5756,7 +5756,7 @@
           <p:cNvPr id="3" name="">
             <a:extLst xmlns:a="http://schemas.openxmlformats.org/drawingml/2006/main">
               <a:ext uri="{FF2B5EF4-FFF2-40B4-BE49-F238E27FC236}">
-                <a16:creationId xmlns:a16="http://schemas.microsoft.com/office/drawing/2014/main" id="{95D95AF0-ACB1-4746-ACF0-C0420816FBA1}"/>
+                <a16:creationId xmlns:a16="http://schemas.microsoft.com/office/drawing/2014/main" id="{BAB176D1-BA9A-4270-B003-5EC05AE88334}"/>
               </a:ext>
             </a:extLst>
           </p:cNvPr>
@@ -5988,7 +5988,7 @@
                 <a:ea typeface="Microsoft YaHei"/>
                 <a:cs typeface="Microsoft YaHei"/>
               </a:rPr>
-              <a:t>B 规则告警：批次、版本化规则、异常事件、通知 attempt</a:t>
+              <a:t>B 告警：批次与版本化规则、异常事件、通知 attempt</a:t>
             </a:r>
           </a:p>
           <a:p xmlns:a="http://schemas.openxmlformats.org/drawingml/2006/main">
@@ -6052,7 +6052,7 @@
           <p:cNvPr id="4" name="">
             <a:extLst xmlns:a="http://schemas.openxmlformats.org/drawingml/2006/main">
               <a:ext uri="{FF2B5EF4-FFF2-40B4-BE49-F238E27FC236}">
-                <a16:creationId xmlns:a16="http://schemas.microsoft.com/office/drawing/2014/main" id="{23ED900A-5BCD-4670-8956-09E862F19464}"/>
+                <a16:creationId xmlns:a16="http://schemas.microsoft.com/office/drawing/2014/main" id="{179339BF-D19E-4EE3-93EC-05F9AC28253C}"/>
               </a:ext>
             </a:extLst>
           </p:cNvPr>
@@ -6062,7 +6062,7 @@
           <p:nvPr/>
         </p:nvPicPr>
         <p:blipFill>
-          <a:blip xmlns:r="http://schemas.openxmlformats.org/officeDocument/2006/relationships" xmlns:a="http://schemas.openxmlformats.org/drawingml/2006/main" r:embed="R436072eb90064181"/>
+          <a:blip xmlns:r="http://schemas.openxmlformats.org/officeDocument/2006/relationships" xmlns:a="http://schemas.openxmlformats.org/drawingml/2006/main" r:embed="R631d938372eb49f2"/>
           <a:stretch xmlns:a="http://schemas.openxmlformats.org/drawingml/2006/main"/>
         </p:blipFill>
         <p:spPr>
@@ -6080,7 +6080,7 @@
           <p:cNvPr id="5" name="">
             <a:extLst xmlns:a="http://schemas.openxmlformats.org/drawingml/2006/main">
               <a:ext uri="{FF2B5EF4-FFF2-40B4-BE49-F238E27FC236}">
-                <a16:creationId xmlns:a16="http://schemas.microsoft.com/office/drawing/2014/main" id="{3E5ABA46-4AD1-40D4-91C1-8E7DCE700DA3}"/>
+                <a16:creationId xmlns:a16="http://schemas.microsoft.com/office/drawing/2014/main" id="{1F135DF5-EB7A-4BD5-A766-9791C3B990C1}"/>
               </a:ext>
             </a:extLst>
           </p:cNvPr>
@@ -6235,7 +6235,7 @@
     </p:spTree>
     <p:extLst>
       <p:ext uri="{BB962C8B-B14F-4D97-AF65-F5344CB8AC3E}">
-        <p14:creationId xmlns:p14="http://schemas.microsoft.com/office/powerpoint/2010/main" val="162940037"/>
+        <p14:creationId xmlns:p14="http://schemas.microsoft.com/office/powerpoint/2010/main" val="1557925327"/>
       </p:ext>
     </p:extLst>
   </p:cSld>
@@ -6266,7 +6266,7 @@
           <p:cNvPr id="6" name="">
             <a:extLst xmlns:a="http://schemas.openxmlformats.org/drawingml/2006/main">
               <a:ext uri="{FF2B5EF4-FFF2-40B4-BE49-F238E27FC236}">
-                <a16:creationId xmlns:a16="http://schemas.microsoft.com/office/drawing/2014/main" id="{B3C26A16-2268-4E34-B40C-A923E23739A8}"/>
+                <a16:creationId xmlns:a16="http://schemas.microsoft.com/office/drawing/2014/main" id="{606F6284-2FB4-40F3-91DB-85C1CF3E1715}"/>
               </a:ext>
             </a:extLst>
           </p:cNvPr>
@@ -6423,7 +6423,7 @@
           <p:cNvPr id="2" name="">
             <a:extLst xmlns:a="http://schemas.openxmlformats.org/drawingml/2006/main">
               <a:ext uri="{FF2B5EF4-FFF2-40B4-BE49-F238E27FC236}">
-                <a16:creationId xmlns:a16="http://schemas.microsoft.com/office/drawing/2014/main" id="{2DC9F19A-5F48-460F-B8FF-BCC9660F3A5F}"/>
+                <a16:creationId xmlns:a16="http://schemas.microsoft.com/office/drawing/2014/main" id="{D5E94EF7-F9E3-43F4-B740-D638B3A067D6}"/>
               </a:ext>
             </a:extLst>
           </p:cNvPr>
@@ -6580,7 +6580,7 @@
           <p:cNvPr id="3" name="">
             <a:extLst xmlns:a="http://schemas.openxmlformats.org/drawingml/2006/main">
               <a:ext uri="{FF2B5EF4-FFF2-40B4-BE49-F238E27FC236}">
-                <a16:creationId xmlns:a16="http://schemas.microsoft.com/office/drawing/2014/main" id="{7210F6C6-AA32-4236-A4B7-0B46FCF6C5AE}"/>
+                <a16:creationId xmlns:a16="http://schemas.microsoft.com/office/drawing/2014/main" id="{5B8355A6-7E75-4653-9CE8-95D82F6254D9}"/>
               </a:ext>
             </a:extLst>
           </p:cNvPr>
@@ -6849,7 +6849,7 @@
           <p:cNvPr id="4" name="">
             <a:extLst xmlns:a="http://schemas.openxmlformats.org/drawingml/2006/main">
               <a:ext uri="{FF2B5EF4-FFF2-40B4-BE49-F238E27FC236}">
-                <a16:creationId xmlns:a16="http://schemas.microsoft.com/office/drawing/2014/main" id="{1CAFB3D0-4DA6-4B68-9CC5-80F1C0C40C9A}"/>
+                <a16:creationId xmlns:a16="http://schemas.microsoft.com/office/drawing/2014/main" id="{3C182FEF-13A1-48AE-AF58-627325348D18}"/>
               </a:ext>
             </a:extLst>
           </p:cNvPr>
@@ -6859,7 +6859,7 @@
           <p:nvPr/>
         </p:nvPicPr>
         <p:blipFill>
-          <a:blip xmlns:r="http://schemas.openxmlformats.org/officeDocument/2006/relationships" xmlns:a="http://schemas.openxmlformats.org/drawingml/2006/main" r:embed="R24466b5d90704f80"/>
+          <a:blip xmlns:r="http://schemas.openxmlformats.org/officeDocument/2006/relationships" xmlns:a="http://schemas.openxmlformats.org/drawingml/2006/main" r:embed="R32dc355687334451"/>
           <a:stretch xmlns:a="http://schemas.openxmlformats.org/drawingml/2006/main"/>
         </p:blipFill>
         <p:spPr>
@@ -6877,7 +6877,7 @@
           <p:cNvPr id="5" name="">
             <a:extLst xmlns:a="http://schemas.openxmlformats.org/drawingml/2006/main">
               <a:ext uri="{FF2B5EF4-FFF2-40B4-BE49-F238E27FC236}">
-                <a16:creationId xmlns:a16="http://schemas.microsoft.com/office/drawing/2014/main" id="{58918C32-F231-4383-9DEB-BAF3F6EA835E}"/>
+                <a16:creationId xmlns:a16="http://schemas.microsoft.com/office/drawing/2014/main" id="{151BA613-0971-436A-A387-754FFA8CC810}"/>
               </a:ext>
             </a:extLst>
           </p:cNvPr>
@@ -7032,7 +7032,7 @@
     </p:spTree>
     <p:extLst>
       <p:ext uri="{BB962C8B-B14F-4D97-AF65-F5344CB8AC3E}">
-        <p14:creationId xmlns:p14="http://schemas.microsoft.com/office/powerpoint/2010/main" val="1943130363"/>
+        <p14:creationId xmlns:p14="http://schemas.microsoft.com/office/powerpoint/2010/main" val="1682376553"/>
       </p:ext>
     </p:extLst>
   </p:cSld>
@@ -7063,7 +7063,7 @@
           <p:cNvPr id="5" name="">
             <a:extLst xmlns:a="http://schemas.openxmlformats.org/drawingml/2006/main">
               <a:ext uri="{FF2B5EF4-FFF2-40B4-BE49-F238E27FC236}">
-                <a16:creationId xmlns:a16="http://schemas.microsoft.com/office/drawing/2014/main" id="{3A969486-8E6B-48B0-AA62-32FE400972E7}"/>
+                <a16:creationId xmlns:a16="http://schemas.microsoft.com/office/drawing/2014/main" id="{EB1281D7-418D-48A2-92AE-DE612369B401}"/>
               </a:ext>
             </a:extLst>
           </p:cNvPr>
@@ -7220,7 +7220,7 @@
           <p:cNvPr id="2" name="">
             <a:extLst xmlns:a="http://schemas.openxmlformats.org/drawingml/2006/main">
               <a:ext uri="{FF2B5EF4-FFF2-40B4-BE49-F238E27FC236}">
-                <a16:creationId xmlns:a16="http://schemas.microsoft.com/office/drawing/2014/main" id="{2F500ECE-413F-472D-B02E-60272788D380}"/>
+                <a16:creationId xmlns:a16="http://schemas.microsoft.com/office/drawing/2014/main" id="{9AE18C01-3C86-42CD-BF02-09F620D7B2CC}"/>
               </a:ext>
             </a:extLst>
           </p:cNvPr>
@@ -7367,7 +7367,7 @@
                 <a:ea typeface="Microsoft YaHei"/>
                 <a:cs typeface="Microsoft YaHei"/>
               </a:rPr>
-              <a:t>main0e 受保护恢复：提交成功且连接释放后才 CAS 领取、fenced 回执，重启不重发。</a:t>
+              <a:t>同一事务内 CAS 领取 → 提交并释放连接 → 锁外发送与回执；重启不重发。</a:t>
             </a:r>
           </a:p>
         </p:txBody>
@@ -7377,7 +7377,7 @@
           <p:cNvPr id="3" name="">
             <a:extLst xmlns:a="http://schemas.openxmlformats.org/drawingml/2006/main">
               <a:ext uri="{FF2B5EF4-FFF2-40B4-BE49-F238E27FC236}">
-                <a16:creationId xmlns:a16="http://schemas.microsoft.com/office/drawing/2014/main" id="{E3648D83-5C79-4570-A648-73C9E6CE29B1}"/>
+                <a16:creationId xmlns:a16="http://schemas.microsoft.com/office/drawing/2014/main" id="{869A48C4-F019-4F39-A3EF-9EC99878D1D9}"/>
               </a:ext>
             </a:extLst>
           </p:cNvPr>
@@ -7968,7 +7968,7 @@
           <p:cNvPr id="4" name="">
             <a:extLst xmlns:a="http://schemas.openxmlformats.org/drawingml/2006/main">
               <a:ext uri="{FF2B5EF4-FFF2-40B4-BE49-F238E27FC236}">
-                <a16:creationId xmlns:a16="http://schemas.microsoft.com/office/drawing/2014/main" id="{5A31AB81-D471-469B-9608-64EB778B51D3}"/>
+                <a16:creationId xmlns:a16="http://schemas.microsoft.com/office/drawing/2014/main" id="{9889A58B-A676-4489-BCBE-BC261237E877}"/>
               </a:ext>
             </a:extLst>
           </p:cNvPr>
@@ -8123,7 +8123,7 @@
     </p:spTree>
     <p:extLst>
       <p:ext uri="{BB962C8B-B14F-4D97-AF65-F5344CB8AC3E}">
-        <p14:creationId xmlns:p14="http://schemas.microsoft.com/office/powerpoint/2010/main" val="1603129675"/>
+        <p14:creationId xmlns:p14="http://schemas.microsoft.com/office/powerpoint/2010/main" val="1919809685"/>
       </p:ext>
     </p:extLst>
   </p:cSld>
@@ -8154,7 +8154,7 @@
           <p:cNvPr id="7" name="">
             <a:extLst xmlns:a="http://schemas.openxmlformats.org/drawingml/2006/main">
               <a:ext uri="{FF2B5EF4-FFF2-40B4-BE49-F238E27FC236}">
-                <a16:creationId xmlns:a16="http://schemas.microsoft.com/office/drawing/2014/main" id="{E9555F7F-A148-4231-B3B7-D369D4B08BBE}"/>
+                <a16:creationId xmlns:a16="http://schemas.microsoft.com/office/drawing/2014/main" id="{59CFB69A-E0DD-4E33-9374-C92F867F0148}"/>
               </a:ext>
             </a:extLst>
           </p:cNvPr>
@@ -8311,7 +8311,7 @@
           <p:cNvPr id="2" name="">
             <a:extLst xmlns:a="http://schemas.openxmlformats.org/drawingml/2006/main">
               <a:ext uri="{FF2B5EF4-FFF2-40B4-BE49-F238E27FC236}">
-                <a16:creationId xmlns:a16="http://schemas.microsoft.com/office/drawing/2014/main" id="{12FE22BC-1B0E-42D8-AA62-4FE70504BDF6}"/>
+                <a16:creationId xmlns:a16="http://schemas.microsoft.com/office/drawing/2014/main" id="{E63CDBB5-8CCE-41D8-8788-92CD36481498}"/>
               </a:ext>
             </a:extLst>
           </p:cNvPr>
@@ -8468,7 +8468,7 @@
           <p:cNvPr id="3" name="">
             <a:extLst xmlns:a="http://schemas.openxmlformats.org/drawingml/2006/main">
               <a:ext uri="{FF2B5EF4-FFF2-40B4-BE49-F238E27FC236}">
-                <a16:creationId xmlns:a16="http://schemas.microsoft.com/office/drawing/2014/main" id="{8D24111F-509B-4C67-8775-E10C7200C3BD}"/>
+                <a16:creationId xmlns:a16="http://schemas.microsoft.com/office/drawing/2014/main" id="{2031287B-1864-4B4E-B264-4E34291A7F56}"/>
               </a:ext>
             </a:extLst>
           </p:cNvPr>
@@ -8737,7 +8737,7 @@
           <p:cNvPr id="4" name="">
             <a:extLst xmlns:a="http://schemas.openxmlformats.org/drawingml/2006/main">
               <a:ext uri="{FF2B5EF4-FFF2-40B4-BE49-F238E27FC236}">
-                <a16:creationId xmlns:a16="http://schemas.microsoft.com/office/drawing/2014/main" id="{49275809-99DA-4582-943A-E3543AE88714}"/>
+                <a16:creationId xmlns:a16="http://schemas.microsoft.com/office/drawing/2014/main" id="{554B1020-C755-48BA-A05E-9B4A73BE581C}"/>
               </a:ext>
             </a:extLst>
           </p:cNvPr>
@@ -8747,7 +8747,7 @@
           <p:nvPr/>
         </p:nvPicPr>
         <p:blipFill>
-          <a:blip xmlns:r="http://schemas.openxmlformats.org/officeDocument/2006/relationships" xmlns:a="http://schemas.openxmlformats.org/drawingml/2006/main" r:embed="Rf11da72ebec84ec4"/>
+          <a:blip xmlns:r="http://schemas.openxmlformats.org/officeDocument/2006/relationships" xmlns:a="http://schemas.openxmlformats.org/drawingml/2006/main" r:embed="Rcf60bb2a75774dea"/>
           <a:stretch xmlns:a="http://schemas.openxmlformats.org/drawingml/2006/main"/>
         </p:blipFill>
         <p:spPr>
@@ -8765,7 +8765,7 @@
           <p:cNvPr id="5" name="">
             <a:extLst xmlns:a="http://schemas.openxmlformats.org/drawingml/2006/main">
               <a:ext uri="{FF2B5EF4-FFF2-40B4-BE49-F238E27FC236}">
-                <a16:creationId xmlns:a16="http://schemas.microsoft.com/office/drawing/2014/main" id="{BCEBB326-2002-4162-97C9-CC0FBD8E9303}"/>
+                <a16:creationId xmlns:a16="http://schemas.microsoft.com/office/drawing/2014/main" id="{F3B2A61C-9FF3-4501-856C-D7867370F483}"/>
               </a:ext>
             </a:extLst>
           </p:cNvPr>
@@ -8973,7 +8973,7 @@
           <p:cNvPr id="6" name="">
             <a:extLst xmlns:a="http://schemas.openxmlformats.org/drawingml/2006/main">
               <a:ext uri="{FF2B5EF4-FFF2-40B4-BE49-F238E27FC236}">
-                <a16:creationId xmlns:a16="http://schemas.microsoft.com/office/drawing/2014/main" id="{CCC02A3E-548C-4C21-BF01-FCD23B153ADD}"/>
+                <a16:creationId xmlns:a16="http://schemas.microsoft.com/office/drawing/2014/main" id="{332ADB09-3677-4730-B2E3-C28109FCB6C3}"/>
               </a:ext>
             </a:extLst>
           </p:cNvPr>
@@ -9128,7 +9128,7 @@
     </p:spTree>
     <p:extLst>
       <p:ext uri="{BB962C8B-B14F-4D97-AF65-F5344CB8AC3E}">
-        <p14:creationId xmlns:p14="http://schemas.microsoft.com/office/powerpoint/2010/main" val="997335597"/>
+        <p14:creationId xmlns:p14="http://schemas.microsoft.com/office/powerpoint/2010/main" val="1764909821"/>
       </p:ext>
     </p:extLst>
   </p:cSld>
@@ -9159,7 +9159,7 @@
           <p:cNvPr id="8" name="">
             <a:extLst xmlns:a="http://schemas.openxmlformats.org/drawingml/2006/main">
               <a:ext uri="{FF2B5EF4-FFF2-40B4-BE49-F238E27FC236}">
-                <a16:creationId xmlns:a16="http://schemas.microsoft.com/office/drawing/2014/main" id="{0F48044C-211F-40D2-9B64-D392E920639E}"/>
+                <a16:creationId xmlns:a16="http://schemas.microsoft.com/office/drawing/2014/main" id="{9DC45862-5E62-4218-B559-2314F5AF3591}"/>
               </a:ext>
             </a:extLst>
           </p:cNvPr>
@@ -9316,7 +9316,7 @@
           <p:cNvPr id="2" name="">
             <a:extLst xmlns:a="http://schemas.openxmlformats.org/drawingml/2006/main">
               <a:ext uri="{FF2B5EF4-FFF2-40B4-BE49-F238E27FC236}">
-                <a16:creationId xmlns:a16="http://schemas.microsoft.com/office/drawing/2014/main" id="{E15E766D-3A31-4366-8061-86B5C8668BF4}"/>
+                <a16:creationId xmlns:a16="http://schemas.microsoft.com/office/drawing/2014/main" id="{0A19FBAF-8F81-4C13-8F8F-064025EF349F}"/>
               </a:ext>
             </a:extLst>
           </p:cNvPr>
@@ -9473,7 +9473,7 @@
           <p:cNvPr id="3" name="">
             <a:extLst xmlns:a="http://schemas.openxmlformats.org/drawingml/2006/main">
               <a:ext uri="{FF2B5EF4-FFF2-40B4-BE49-F238E27FC236}">
-                <a16:creationId xmlns:a16="http://schemas.microsoft.com/office/drawing/2014/main" id="{961BFFA7-5F01-4A72-9534-79949ACC6C09}"/>
+                <a16:creationId xmlns:a16="http://schemas.microsoft.com/office/drawing/2014/main" id="{5ED45224-19FE-45EE-84BE-55CC5E21E4DE}"/>
               </a:ext>
             </a:extLst>
           </p:cNvPr>
@@ -9715,7 +9715,7 @@
           <p:cNvPr id="4" name="">
             <a:extLst xmlns:a="http://schemas.openxmlformats.org/drawingml/2006/main">
               <a:ext uri="{FF2B5EF4-FFF2-40B4-BE49-F238E27FC236}">
-                <a16:creationId xmlns:a16="http://schemas.microsoft.com/office/drawing/2014/main" id="{C66D1D74-1482-4BE0-8F30-AA99B2FC982E}"/>
+                <a16:creationId xmlns:a16="http://schemas.microsoft.com/office/drawing/2014/main" id="{27197307-48A6-4B17-8464-85EF9CE5A2AF}"/>
               </a:ext>
             </a:extLst>
           </p:cNvPr>
@@ -9872,7 +9872,7 @@
           <p:cNvPr id="5" name="">
             <a:extLst xmlns:a="http://schemas.openxmlformats.org/drawingml/2006/main">
               <a:ext uri="{FF2B5EF4-FFF2-40B4-BE49-F238E27FC236}">
-                <a16:creationId xmlns:a16="http://schemas.microsoft.com/office/drawing/2014/main" id="{B17EC375-A622-40F8-AC89-845ED673EEBF}"/>
+                <a16:creationId xmlns:a16="http://schemas.microsoft.com/office/drawing/2014/main" id="{C5B9852B-4434-4CBF-B068-A3BB5713845B}"/>
               </a:ext>
             </a:extLst>
           </p:cNvPr>
@@ -10077,7 +10077,7 @@
                 <a:ea typeface="Microsoft YaHei"/>
                 <a:cs typeface="Microsoft YaHei"/>
               </a:rPr>
-              <a:t>C 自动恢复与多批高温业务收尾</a:t>
+              <a:t>已证分段的同版联合验收与材料收尾</a:t>
             </a:r>
           </a:p>
           <a:p xmlns:a="http://schemas.openxmlformats.org/drawingml/2006/main">
@@ -10114,7 +10114,7 @@
           <p:cNvPr id="6" name="">
             <a:extLst xmlns:a="http://schemas.openxmlformats.org/drawingml/2006/main">
               <a:ext uri="{FF2B5EF4-FFF2-40B4-BE49-F238E27FC236}">
-                <a16:creationId xmlns:a16="http://schemas.microsoft.com/office/drawing/2014/main" id="{C82176F8-3455-4CA3-AA19-186D76CCDDCB}"/>
+                <a16:creationId xmlns:a16="http://schemas.microsoft.com/office/drawing/2014/main" id="{6AA8A20A-376A-4A15-BB34-A5B29FC25D70}"/>
               </a:ext>
             </a:extLst>
           </p:cNvPr>
@@ -10271,7 +10271,7 @@
           <p:cNvPr id="7" name="">
             <a:extLst xmlns:a="http://schemas.openxmlformats.org/drawingml/2006/main">
               <a:ext uri="{FF2B5EF4-FFF2-40B4-BE49-F238E27FC236}">
-                <a16:creationId xmlns:a16="http://schemas.microsoft.com/office/drawing/2014/main" id="{4D7CE749-D5F0-4F96-9073-66AFACD8B810}"/>
+                <a16:creationId xmlns:a16="http://schemas.microsoft.com/office/drawing/2014/main" id="{CA55AFA9-61C8-41F7-9F98-2A690742734A}"/>
               </a:ext>
             </a:extLst>
           </p:cNvPr>
@@ -10426,7 +10426,7 @@
     </p:spTree>
     <p:extLst>
       <p:ext uri="{BB962C8B-B14F-4D97-AF65-F5344CB8AC3E}">
-        <p14:creationId xmlns:p14="http://schemas.microsoft.com/office/powerpoint/2010/main" val="74706369"/>
+        <p14:creationId xmlns:p14="http://schemas.microsoft.com/office/powerpoint/2010/main" val="695506020"/>
       </p:ext>
     </p:extLst>
   </p:cSld>

</xml_diff>